<commit_message>
docs: polish final presentation language and verify artifacts
</commit_message>
<xml_diff>
--- a/final-deliverables/PasswordGuard_Presentation.pptx
+++ b/final-deliverables/PasswordGuard_Presentation.pptx
@@ -511,7 +511,7 @@
           <a:lstStyle/>
           <a:p>
             <a:r>
-              <a:t>Hello everyone, and welcome to our presentation on PasswordGuard: An Experimental Analysis of Password Strength and Authentication Security. Before we start, let me ask our audience a quick question: Which of these two passwords do you think is stronger? Option A: P@ssw0rd123, with symbols and numbers, or Option B: correct-horse-battery-staple, four simple lowercase words? Many people instinctively choose Option A because of the special characters. However, as we will explore today, Option B has a vastly larger mathematical search space. Let us examine why password security remains such a critical challenge.</a:t>
+              <a:t>Good morning, teacher and classmates. Today, our team is happy to present our project: PasswordGuard. Before we start, I want to ask everyone a quick question: Which of these two passwords do you think is stronger against a computer attack? Option A: P@ssw0rd123, or Option B: correct-horse-battery-staple? Many people choose Option A because of the special characters. But under a simple exhaustive search-space model, Option B actually has a much larger theoretical search space. However, real password security also depends on predictability, hashing, rate limiting, and other defenses. Let us look at why passwords are still such a big challenge.</a:t>
             </a:r>
           </a:p>
         </p:txBody>
@@ -581,7 +581,7 @@
           <a:lstStyle/>
           <a:p>
             <a:r>
-              <a:t>In conclusion, we must emphasize our project's academic limitations. Because the scoring rules and evaluation engine share the same heuristic, our experiment evaluates internal rule consistency rather than real-world cracking immunity. Our synthetic dataset and uniform entropy calculations are educational models. Nonetheless, the core takeaways are clear: first, password length dominates character variety through exponential growth. Second, superficial complexity like 'Password123!' fails against modern attack tools. And third, authentic authentication security requires defense in depth—combining memorable passphrases with password managers, slow memory-hard hashing like Argon2id, and universal Multi-Factor Authentication. Thank you very much for your time and attention. We are now ready to answer any questions!</a:t>
+              <a:t>To be academically honest, we must acknowledge our project's limitations: First, circularity: the experiment evaluates the internal consistency of our heuristic rules, rather than testing real-world cracking resistance. Second, our synthetic dataset does not capture the full variety of real user passwords. Third, our entropy estimate assumes uniform random selection, while real human passwords have predictable habits. Despite these limitations, our core security takeaways are clear: in simple search-space models, length provides an exponential advantage, superficial complexity fails, and defense in depth is essential—combining password managers, slow memory-hard hashing, and Multi-Factor Authentication. Thank you very much for your time. We are now ready to answer your questions!</a:t>
             </a:r>
           </a:p>
         </p:txBody>
@@ -651,7 +651,7 @@
           <a:lstStyle/>
           <a:p>
             <a:r>
-              <a:t>Why is password security such an enduring problem? Modern users manage dozens of accounts. Because truly random strings are hard to memorize, users predictably take cognitive shortcuts—reusing passwords or adding simple substitutions like an exclamation mark at the end. Meanwhile, attackers exploit leaked wordlists and automated botnets. Even worse, traditional complexity rules produced an illusion of security: people wrote passwords like 'Summer2024!', which modern attack tools crack almost instantly. PasswordGuard was created to make these mathematical realities transparent and accessible through hands-on interaction.</a:t>
+              <a:t>Why are passwords still broken so often? First, users manage 50 or more accounts. Random strings are very hard to remember, so people take predictable shortcuts: reusing passwords or replacing the letter 'a' with '@'. Second, attackers use automated tools with wordlists of millions of leaked passwords. Third, old complexity rules created a false sense of security: asking for one capital letter and one number taught people to write 'Summer2024!', which guessing tools test very early. PasswordGuard helps students see these risks through an interactive tool.</a:t>
             </a:r>
           </a:p>
         </p:txBody>
@@ -721,7 +721,7 @@
           <a:lstStyle/>
           <a:p>
             <a:r>
-              <a:t>How do passwords work mathematically? In the prover-verifier model, the server stores a cryptographic verifier, not plaintext. If an attacker performs brute-force guessing, the theoretical search space equals R to the power of L, where R is the character pool and L is length. Notice that length is the exponent! Look at the comparison on the right: an 8-character password using all 95 printable characters yields about 6.6 times 10 to the 15th combinations. At an assumed rate of 10 to the 11th guesses per second, that could be tested in roughly 9 hours. In contrast, a 28-character passphrase using only lowercase letters and hyphens yields 1.2 times 10 to the 40th combinations—taking over 10 to the 21st years. Length dominates character variety.</a:t>
+              <a:t>To understand password defense, we can look at a simple mathematical model. In modern systems, the user proves knowledge of a secret, while the server verifies it against a stored cryptographic verifier. Under exhaustive brute force, total combinations equal R to the power of L. In this theoretical model, increasing length has an exponential effect because length is the exponent. An 8-character password with all ASCII characters yields about 6.6 times 10 to the 15th combinations. In contrast, a 28-character passphrase yields about 1.2 times 10 to the 40th combinations. Notice that the guessing times shown are illustrative assumed rates, not a hardware benchmark.</a:t>
             </a:r>
           </a:p>
         </p:txBody>
@@ -791,7 +791,7 @@
           <a:lstStyle/>
           <a:p>
             <a:r>
-              <a:t>Let us examine how passwords are attacked and defended. In the real world, attackers rarely try every character uniformly. Instead, they run dictionary words through mutation rules, replay breached passwords in automated credential-stuffing attacks, and crack leaked database dumps offline on GPU clusters. Phishing bypasses password complexity entirely. This proves that password security is not the same as authentication security. A resilient defense requires defense in depth: users must adopt password managers to keep credentials unique, enable Multi-Factor Authentication so stolen passwords alone are insufficient, and servers must employ slow memory-hard hashing like Argon2id alongside strict rate limiting.</a:t>
+              <a:t>In the real world, attackers use several methods: wordlists, credential stuffing across sites, offline hash recovery, and phishing. Because of these threats, password strength alone cannot guarantee security. We need defense in depth: password managers so every account has a unique password, Multi-Factor Authentication so a stolen password alone is not enough, and slow memory-hard hashing alongside rate limiting.</a:t>
             </a:r>
           </a:p>
         </p:txBody>
@@ -861,7 +861,7 @@
           <a:lstStyle/>
           <a:p>
             <a:r>
-              <a:t>To explore these concepts practically, we designed and built PasswordGuard. PasswordGuard is a single-page web application built with React, TypeScript, and Vite. A critical design choice was our client-side processing model: all password evaluation, entropy estimation, and hashing occur locally in the browser memory context. There is no application backend, no external database, and no network logging. Users can safely test example passwords without third-party exposure. For cryptographic operations, we interface directly with the browser's native Web Crypto API.</a:t>
+              <a:t>To demonstrate these ideas, we built PasswordGuard. PasswordGuard is a single-page web app built with React, TypeScript, and Vite. A key design choice is our local processing approach: PasswordGuard is designed to process entered passwords locally in the browser. It does not include an application backend for password submission, and it does not store passwords in a database or send tracking data. For cryptographic hashing, the app uses the browser's built-in Web Crypto API.</a:t>
             </a:r>
           </a:p>
         </p:txBody>
@@ -931,7 +931,7 @@
           <a:lstStyle/>
           <a:p>
             <a:r>
-              <a:t>How does PasswordGuard evaluate password strength? We implement two distinct metrics. First, a transparent heuristic score from 0 to 100. It awards points for length and character sets, adds bonuses for diversity and multi-word passphrases, and deducts targeted penalties for sequential runs, repetitions, and dictionary roots. The score classifies passwords into Weak, Medium, or Strong. Second, we calculate a theoretical character-space entropy estimate in bits, assuming uniform random selection. To make this intuitive, we project illustrative search times across three assumed guessing scenarios: 100 guesses per second for rate-limited online logins, 10 million per second for offline CPU attacks, and 100 billion per second for GPU rigs targeting fast hashes. We emphasize that these are educational mathematical projections, not hardware benchmarks.</a:t>
+              <a:t>PasswordGuard evaluates passwords using two main metrics: First, a transparent heuristic score from 0 to 100. It awards length points up to 40 using tiered brackets, variety points up to 35, diversity bonuses up to 15, and passphrase bonuses up to 20 for long passphrases with diverse characters or word separators. The heuristic subtracts penalties for sequential patterns, repeated characters, dictionary roots, and short lengths. The final score classifies passwords into Weak, Medium, or Strong. Second, the app calculates a theoretical character-space entropy estimate in bits, assuming uniform random selection.</a:t>
             </a:r>
           </a:p>
         </p:txBody>
@@ -1001,7 +1001,7 @@
           <a:lstStyle/>
           <a:p>
             <a:r>
-              <a:t>Next, let us examine how servers protect passwords during storage. Passwords should never be stored in plain text. A cryptographic hash is a one-way transformation that maps arbitrary input to a fixed-length digest. We also demonstrate the necessity of cryptographic salts. By appending a unique 16-byte random salt to each password, two identical passwords produce completely different digests. This completely neutralizes precomputed rainbow table lookups. However, we must state an important security distinction: SHA-256 is used in PasswordGuard solely for educational clarity. Because SHA-256 is designed to be fast, production authentication backends should never use raw SHA-256. Production systems must use slow, memory-hard key derivation functions like Argon2id or bcrypt.</a:t>
+              <a:t>Servers should never store passwords in plain text. Instead, they store a cryptographic hash. A hash function is one-way: easy to compute forward, but practically impossible to reverse. A well-designed hash exhibits an avalanche effect: a small input change tends to change roughly half of the output bits. To protect stored hashes, servers add a unique random salt for each user. Unique salts make traditional precomputed rainbow-table attacks impractical across many users. Important security distinction: PasswordGuard uses SHA-256 only for educational demonstration in the browser. Because SHA-256 is a fast general-purpose hash, raw SHA-256 is not appropriate for production password storage. Production systems should use password-focused functions such as Argon2id, bcrypt, scrypt, or PBKDF2 with appropriate parameters.</a:t>
             </a:r>
           </a:p>
         </p:txBody>
@@ -1071,7 +1071,7 @@
           <a:lstStyle/>
           <a:p>
             <a:r>
-              <a:t>To test our scoring heuristic systematically, we conducted a controlled experiment. In accordance with research ethics principles, we did not use real user credentials or breached password dumps. Instead, we constructed a synthetic dataset of 150 passwords partitioned into five distinct structural categories of 30 samples each. Category A represents short simple words. Category B reflects common human patterns with dictionary roots and appended numbers. Category C represents enterprise complexity guidelines. Category D contains long multi-word passphrases. And Category E consists of 16-character pseudo-random strings across all character sets. We evaluated all 150 samples to observe how consistently our heuristic behaves across these structures.</a:t>
+              <a:t>To test whether our scoring rules behave consistently, we ran a controlled experiment. To follow research ethics, we did not use real user credentials or leaked databases. Instead, we tested a controlled synthetic dataset of 150 passwords, divided into five categories of 30 passwords each: Category A: Short Simple, Category B: Common Pattern, Category C: Medium Complexity, Category D: Long Passphrases, and Category E: Long Random. We ran all 150 passwords through our analyzer using an automated test script.</a:t>
             </a:r>
           </a:p>
         </p:txBody>
@@ -1141,7 +1141,7 @@
           <a:lstStyle/>
           <a:p>
             <a:r>
-              <a:t>Here are the quantitative results from our frozen experiment. Across the 150 synthetic samples, 59 were classified as Weak, 12 as Medium, and 79 as Strong by our heuristic. As seen in the chart, Category E achieved the highest average score of 90.0, with 100% rated Strong. Category D, the long passphrases, achieved the highest theoretical entropy estimate of 182.9 bits, with 70% Strong and 30% Medium. In contrast, look at Category B: even though these passwords contained uppercase letters, digits, and exclamation marks, their average score plummeted to 10.5, with 96.7% rated Weak. This confirms that our heuristic successfully penalizes predictable patterns rather than relying on superficial character checks. Category A averaged only 2.0, correctly reflecting tiny search spaces.</a:t>
+              <a:t>Here are the empirical results from our experiment. Across all 150 synthetic passwords, our heuristic classified 59 as Weak, 12 as Medium, and 79 as Strong. Looking at the chart: Category E had the highest average score of 90.0 out of 100, with 100% rated Strong. Category D had the highest theoretical entropy estimate of 182.9 bits, with 70% Strong and 30% Medium. Category C averaged 80.8 out of 100, with 93.3% Strong. Now look at Category B: even though these passwords contained uppercase letters, digits, and symbols, their average score collapsed to 10.5 out of 100, and 96.7% were rated Weak. This demonstrates that our heuristic heavily penalizes common patterns. Category A averaged 2.0 out of 100.</a:t>
             </a:r>
           </a:p>
         </p:txBody>
@@ -4527,7 +4527,7 @@
               </a:defRPr>
             </a:pPr>
             <a:r>
-              <a:t>Before we begin, which password do you believe offers stronger mathematical resistance?</a:t>
+              <a:t>Before we begin, which password do you believe offers stronger resistance?</a:t>
             </a:r>
           </a:p>
           <a:p>
@@ -4572,7 +4572,7 @@
               </a:defRPr>
             </a:pPr>
             <a:r>
-              <a:t>Today, we demonstrate why intuitive human perceptions often diverge from combinatorial mathematics.</a:t>
+              <a:t>Under a simple search-space model, Option B has a much larger theoretical search space.</a:t>
             </a:r>
           </a:p>
         </p:txBody>
@@ -4872,7 +4872,7 @@
               </a:defRPr>
             </a:pPr>
             <a:r>
-              <a:t>• Circularity Constraint: The experiment demonstrates internal behavioral consistency of the heuristic, NOT an independent real-world cracking proof.</a:t>
+              <a:t>• Circularity Constraint: The experiment evaluates internal heuristic consistency rather than real-world cracking resistance.</a:t>
             </a:r>
           </a:p>
           <a:p>
@@ -4888,7 +4888,7 @@
               </a:defRPr>
             </a:pPr>
             <a:r>
-              <a:t>• Synthetic Dataset Scope: A controlled synthetic sample (N=150) isolates structural variables but does not replicate the full behavioral distribution of real user passwords.</a:t>
+              <a:t>• Synthetic Dataset Scope: 150 synthetic samples isolate structural rules, but do not capture the full variety of real user passwords.</a:t>
             </a:r>
           </a:p>
           <a:p>
@@ -4904,7 +4904,7 @@
               </a:defRPr>
             </a:pPr>
             <a:r>
-              <a:t>• Theoretical Entropy Bounds: The metric E = L × log₂(R) assumes ideal uniform random selection, whereas human passwords exhibit significant natural language bias.</a:t>
+              <a:t>• Theoretical Entropy Bounds: The metric E = L × log₂(R) assumes ideal uniform random selection, whereas human passwords exhibit predictable habits.</a:t>
             </a:r>
           </a:p>
           <a:p>
@@ -5084,7 +5084,7 @@
               </a:defRPr>
             </a:pPr>
             <a:r>
-              <a:t>• Length Dominates Exponent: Password length expands the theoretical search space exponentially (R^L). Passphrases provide an effective, memorable defense.</a:t>
+              <a:t>• Length Effect: In simple search-space models, password length provides an exponential advantage (R^L), making passphrases an effective approach.</a:t>
             </a:r>
           </a:p>
           <a:p>
@@ -5100,7 +5100,7 @@
               </a:defRPr>
             </a:pPr>
             <a:r>
-              <a:t>• Superficial Complexity Fails: Appending '123!' or capitalizing the first letter does not deceive modern attack tools.</a:t>
+              <a:t>• Superficial Complexity Fails: Appending '123!' or capitalizing the first letter does not protect against modern attack tools.</a:t>
             </a:r>
           </a:p>
           <a:p>
@@ -5116,7 +5116,7 @@
               </a:defRPr>
             </a:pPr>
             <a:r>
-              <a:t>• Password ≠ Authentication Security: Strong passwords alone cannot stop phishing or credential stuffing; authentication requires defense in depth.</a:t>
+              <a:t>• Password ≠ Authentication Security: Password strength alone does not stop phishing or credential stuffing; authentication requires defense in depth.</a:t>
             </a:r>
           </a:p>
           <a:p>
@@ -5129,7 +5129,7 @@
               </a:defRPr>
             </a:pPr>
             <a:r>
-              <a:t>• Essential Defense Triad: 1. Password managers for unique credentials. 2. Slow memory-hard hashing (Argon2id). 3. Universal Multi-Factor Authentication (MFA).</a:t>
+              <a:t>• Essential Defense Triad: 1. Password managers for unique credentials. 2. Slow memory-hard hashing (Argon2id). 3. Multi-Factor Authentication (MFA).</a:t>
             </a:r>
           </a:p>
         </p:txBody>
@@ -5525,7 +5525,7 @@
               </a:defRPr>
             </a:pPr>
             <a:r>
-              <a:t>• Account Overload: Users manage 50 to 100 online accounts across personal and academic services.</a:t>
+              <a:t>• Account Overload: Users manage 50 or more online accounts across various services.</a:t>
             </a:r>
           </a:p>
           <a:p>
@@ -5541,7 +5541,7 @@
               </a:defRPr>
             </a:pPr>
             <a:r>
-              <a:t>• Memory Constraints: Random, high-entropy character strings are cognitively difficult for humans to retain.</a:t>
+              <a:t>• Memory Limits: Truly random strings are very difficult for human memory to retain.</a:t>
             </a:r>
           </a:p>
           <a:p>
@@ -5557,7 +5557,7 @@
               </a:defRPr>
             </a:pPr>
             <a:r>
-              <a:t>• Predictable Shortcuts: Users predictably fall back on simple dictionary roots, birthdays, and repeated substitutions (e.g., 'a' -&gt; '@').</a:t>
+              <a:t>• Predictable Shortcuts: Users predictably rely on common words, birthdays, and simple substitutions (e.g., 'a' -&gt; '@').</a:t>
             </a:r>
           </a:p>
           <a:p>
@@ -5570,7 +5570,7 @@
               </a:defRPr>
             </a:pPr>
             <a:r>
-              <a:t>• Credential Reuse: The same root password is frequently reused across multiple websites, creating cascading breach risks.</a:t>
+              <a:t>• Password Reuse: The same password is frequently reused across multiple websites.</a:t>
             </a:r>
           </a:p>
         </p:txBody>
@@ -5737,7 +5737,7 @@
               </a:defRPr>
             </a:pPr>
             <a:r>
-              <a:t>• Leaked Wordlists: Attackers exploit precomputed wordlists (e.g., RockYou with 32M+ entries) and pattern mutation rules.</a:t>
+              <a:t>• Leaked Wordlists: Attackers exploit large collections of breached passwords (such as RockYou) and common mutation rules.</a:t>
             </a:r>
           </a:p>
           <a:p>
@@ -5753,7 +5753,7 @@
               </a:defRPr>
             </a:pPr>
             <a:r>
-              <a:t>• High-Rate Offline Guessing: Unsalted or fast cryptographic hashes allow specialized GPU rigs to evaluate billions of guesses per second.</a:t>
+              <a:t>• Offline Hash Recovery: Unsalted or fast hashes make large-scale offline guessing cheaper if database dumps leak.</a:t>
             </a:r>
           </a:p>
           <a:p>
@@ -5769,7 +5769,7 @@
               </a:defRPr>
             </a:pPr>
             <a:r>
-              <a:t>• Credential Stuffing: Automated botnets test dumped credential pairs across unrelated platforms with zero manual effort.</a:t>
+              <a:t>• Credential Stuffing: Automated bots test dumped credentials across unrelated login portals.</a:t>
             </a:r>
           </a:p>
           <a:p>
@@ -5782,7 +5782,7 @@
               </a:defRPr>
             </a:pPr>
             <a:r>
-              <a:t>• Phishing &amp; Interception: Social engineering bypasses password complexity entirely by intercepting plaintext directly.</a:t>
+              <a:t>• Phishing: Deceptive websites trick users into typing passwords directly, bypassing complexity.</a:t>
             </a:r>
           </a:p>
         </p:txBody>
@@ -5949,7 +5949,7 @@
               </a:defRPr>
             </a:pPr>
             <a:r>
-              <a:t>• Superficial Rules: Legacy policies demanding 1 uppercase, 1 digit, and 1 symbol produce predictable templates like 'Spring2024!'.</a:t>
+              <a:t>• Predictable Patterns: Demanding one uppercase and one digit produces predictable patterns like 'Summer2024!'.</a:t>
             </a:r>
           </a:p>
           <a:p>
@@ -5965,7 +5965,7 @@
               </a:defRPr>
             </a:pPr>
             <a:r>
-              <a:t>• NIST SP 800-63B Shift: Modern standards discourage arbitrary character composition rules and frequent periodic expiration.</a:t>
+              <a:t>• Targeted Early: Modern password-guessing tools test these common structures very early.</a:t>
             </a:r>
           </a:p>
           <a:p>
@@ -5981,7 +5981,7 @@
               </a:defRPr>
             </a:pPr>
             <a:r>
-              <a:t>• The Education Gap: Most users have never seen how password length mathematically dominates character alphabet expansion.</a:t>
+              <a:t>• NIST SP 800-63B Shift: Modern guidelines discourage arbitrary composition rules and frequent expiration.</a:t>
             </a:r>
           </a:p>
           <a:p>
@@ -5994,7 +5994,7 @@
               </a:defRPr>
             </a:pPr>
             <a:r>
-              <a:t>• PasswordGuard Purpose: An interactive educational platform to demonstrate password heuristics, theoretical entropy, and salting.</a:t>
+              <a:t>• PasswordGuard Purpose: An interactive educational tool demonstrating password heuristics, theoretical entropy, and salting.</a:t>
             </a:r>
           </a:p>
         </p:txBody>
@@ -6310,7 +6310,7 @@
               </a:defRPr>
             </a:pPr>
             <a:r>
-              <a:t>In client-server authentication, the user (prover) proves knowledge of a secret without the server storing plaintext. The server validates against a stored cryptographic verifier.</a:t>
+              <a:t>In client-server authentication, the user proves knowledge of a secret without the server storing plaintext. The server validates against a stored cryptographic verifier.</a:t>
             </a:r>
           </a:p>
           <a:p>
@@ -6374,7 +6374,7 @@
               </a:defRPr>
             </a:pPr>
             <a:r>
-              <a:t>• R = Active character pool size (e.g., 26 letters, 62 alphanumeric, 95 printable ASCII).</a:t>
+              <a:t>• R = Active character pool size (e.g., 26 lowercase, 62 alphanumeric, 95 printable ASCII).</a:t>
             </a:r>
           </a:p>
           <a:p>
@@ -6403,7 +6403,7 @@
               </a:defRPr>
             </a:pPr>
             <a:r>
-              <a:t>Critical Takeaway: Length (L) is in the exponent! Increasing length expands the theoretical search space exponentially, while expanding character pool (R) only increases the base.</a:t>
+              <a:t>Key Mathematical Observation: Length (L) is the exponent! In this theoretical search-space model, increasing length has an exponential effect.</a:t>
             </a:r>
           </a:p>
         </p:txBody>
@@ -6590,7 +6590,7 @@
             </a:r>
             <a:br/>
             <a:r>
-              <a:t>Theoretical Entropy ≈ 37.6 bits | At 10¹¹ guesses/s: ≈ 1.05 seconds!</a:t>
+              <a:t>Theoretical Entropy ≈ 37.6 bits | At 10¹¹ guesses/s (assumed): ≈ 1.05 seconds</a:t>
             </a:r>
           </a:p>
           <a:p>
@@ -6626,7 +6626,7 @@
             </a:r>
             <a:br/>
             <a:r>
-              <a:t>Theoretical Entropy ≈ 52.6 bits | At 10¹¹ guesses/s: ≈ 9.2 hours</a:t>
+              <a:t>Theoretical Entropy ≈ 52.6 bits | At 10¹¹ guesses/s (assumed): ≈ 9.2 hours</a:t>
             </a:r>
           </a:p>
           <a:p>
@@ -6647,6 +6647,9 @@
           </a:p>
           <a:p>
             <a:pPr>
+              <a:spcAft>
+                <a:spcPts val="600"/>
+              </a:spcAft>
               <a:defRPr sz="1000" b="0" i="0">
                 <a:solidFill>
                   <a:srgbClr val="F5F7FA"/>
@@ -6659,7 +6662,20 @@
             </a:r>
             <a:br/>
             <a:r>
-              <a:t>Theoretical Entropy ≈ 133.2 bits | At 10¹¹ guesses/s: ≈ 1.9 × 10²¹ years!</a:t>
+              <a:t>Theoretical Entropy ≈ 133.2 bits | At 10¹¹ guesses/s (assumed): ≈ 1.9 × 10²¹ years</a:t>
+            </a:r>
+          </a:p>
+          <a:p>
+            <a:pPr>
+              <a:defRPr sz="900" b="0" i="1">
+                <a:solidFill>
+                  <a:srgbClr val="A5B2C6"/>
+                </a:solidFill>
+                <a:latin typeface="Arial"/>
+              </a:defRPr>
+            </a:pPr>
+            <a:r>
+              <a:t>*Note: Guessing times shown are assumed illustrative rates, not a hardware benchmark.</a:t>
             </a:r>
           </a:p>
         </p:txBody>
@@ -6975,7 +6991,7 @@
               </a:defRPr>
             </a:pPr>
             <a:r>
-              <a:t>Attackers rarely guess uniformly. They prioritize human wordlists (e.g. RockYou) and apply automated mutation rules (leetspeak, appending years).</a:t>
+              <a:t>Attackers prioritize common human wordlists and apply automated mutation rules (such as leetspeak substitutions).</a:t>
             </a:r>
           </a:p>
           <a:p>
@@ -7007,7 +7023,7 @@
               </a:defRPr>
             </a:pPr>
             <a:r>
-              <a:t>Automated replay of stolen username-password dumps against thousands of unrelated login portals, capitalizing on widespread user credential reuse.</a:t>
+              <a:t>Automated tools replay stolen username and password pairs across many online services, exploiting password reuse.</a:t>
             </a:r>
           </a:p>
           <a:p>
@@ -7039,7 +7055,7 @@
               </a:defRPr>
             </a:pPr>
             <a:r>
-              <a:t>When unsalted or fast hashes (MD5, SHA-1, SHA-256) leak from backend databases, attackers perform unthrottled GPU recovery without server lockouts.</a:t>
+              <a:t>When unsalted or fast hashes leak from a database, attackers test guesses offline without triggering server lockouts.</a:t>
             </a:r>
           </a:p>
           <a:p>
@@ -7068,7 +7084,7 @@
               </a:defRPr>
             </a:pPr>
             <a:r>
-              <a:t>Adversaries manipulate human trust through deceptive sites, harvesting raw credentials directly regardless of password complexity.</a:t>
+              <a:t>Deceptive websites trick users into typing passwords directly, bypassing password complexity entirely.</a:t>
             </a:r>
           </a:p>
         </p:txBody>
@@ -7251,7 +7267,7 @@
               </a:defRPr>
             </a:pPr>
             <a:r>
-              <a:t>Generate, store, and autofill cryptographically random, 20+ character passwords unique to every site—neutralizing credential stuffing.</a:t>
+              <a:t>Generate and store unique, high-entropy passwords for every website, neutralizing credential stuffing.</a:t>
             </a:r>
           </a:p>
           <a:p>
@@ -7283,7 +7299,7 @@
               </a:defRPr>
             </a:pPr>
             <a:r>
-              <a:t>Enforce independent factors (TOTP apps or FIDO2/WebAuthn hardware keys). Even if a password leaks, unauthorized access is denied.</a:t>
+              <a:t>Enforce an independent secondary factor (authenticator app or security key) so a stolen password alone is not enough.</a:t>
             </a:r>
           </a:p>
           <a:p>
@@ -7315,7 +7331,7 @@
               </a:defRPr>
             </a:pPr>
             <a:r>
-              <a:t>Use dedicated Key Derivation Functions (Argon2id, bcrypt, scrypt) with unique salts to impose severe computational costs on offline attackers.</a:t>
+              <a:t>Use dedicated functions (Argon2id, bcrypt, scrypt) with unique salts to increase the computational cost per guess.</a:t>
             </a:r>
           </a:p>
           <a:p>
@@ -7344,7 +7360,7 @@
               </a:defRPr>
             </a:pPr>
             <a:r>
-              <a:t>Throttling login endpoints at the network perimeter neutralizes online automated guessing and credential stuffing botnets.</a:t>
+              <a:t>Throttling login endpoints at the network perimeter limits automated online brute-force attempts.</a:t>
             </a:r>
           </a:p>
         </p:txBody>
@@ -7676,7 +7692,7 @@
               </a:defRPr>
             </a:pPr>
             <a:r>
-              <a:t>• Strict Browser Execution Context:</a:t>
+              <a:t>• Browser-Side Processing:</a:t>
             </a:r>
           </a:p>
           <a:p>
@@ -7692,7 +7708,7 @@
               </a:defRPr>
             </a:pPr>
             <a:r>
-              <a:t>All analysis logic, scoring calculations, and hashing routines execute entirely inside the user's browser runtime.</a:t>
+              <a:t>Designed to process entered passwords locally in the browser runtime.</a:t>
             </a:r>
           </a:p>
           <a:p>
@@ -7708,7 +7724,7 @@
               </a:defRPr>
             </a:pPr>
             <a:r>
-              <a:t>• Zero Server Transmission:</a:t>
+              <a:t>• No Password-Submission Backend:</a:t>
             </a:r>
           </a:p>
           <a:p>
@@ -7724,7 +7740,7 @@
               </a:defRPr>
             </a:pPr>
             <a:r>
-              <a:t>PasswordGuard operates with no application backend, no remote database, and no tracking telemetry. Entered credentials are not sent over any network.</a:t>
+              <a:t>PasswordGuard does not include an application backend for credential submission, and does not store passwords in a database or send tracking data.</a:t>
             </a:r>
           </a:p>
           <a:p>
@@ -7756,7 +7772,7 @@
               </a:defRPr>
             </a:pPr>
             <a:r>
-              <a:t>Utilizes window.crypto.subtle for cryptographic hashing and crypto.getRandomValues for 16-byte random salt generation.</a:t>
+              <a:t>Uses window.crypto.subtle for cryptographic hashing and crypto.getRandomValues for random salt generation.</a:t>
             </a:r>
           </a:p>
           <a:p>
@@ -7772,7 +7788,7 @@
               </a:defRPr>
             </a:pPr>
             <a:r>
-              <a:t>• Modular Component Architecture:</a:t>
+              <a:t>• Modular Component Structure:</a:t>
             </a:r>
           </a:p>
           <a:p>
@@ -7785,7 +7801,7 @@
               </a:defRPr>
             </a:pPr>
             <a:r>
-              <a:t>Clean separation of concerns: Password Input, Strength Meter, Security Checklist, Cracking Time Estimator, and Hashing Lab.</a:t>
+              <a:t>Separated components for password analysis, strength meter, security checklist, cracking projections, and hashing demo.</a:t>
             </a:r>
           </a:p>
         </p:txBody>
@@ -8284,13 +8300,13 @@
               </a:defRPr>
             </a:pPr>
             <a:r>
-              <a:t>Scoring Mechanics:</a:t>
+              <a:t>Verified Scoring Rules from Code:</a:t>
             </a:r>
           </a:p>
           <a:p>
             <a:pPr>
               <a:spcAft>
-                <a:spcPts val="600"/>
+                <a:spcPts val="500"/>
               </a:spcAft>
               <a:defRPr sz="1000" b="0" i="0">
                 <a:solidFill>
@@ -8300,13 +8316,13 @@
               </a:defRPr>
             </a:pPr>
             <a:r>
-              <a:t>• Base Length Score: Up to 40 points (+4 pts/char up to 6; +2.5 pts/char up to 10; +1 pt/char beyond 10).</a:t>
+              <a:t>• Length Brackets: Up to 40 pts (4 pts &lt;6, 10 pts for 6–7, 20 pts for 8–11, 32 pts for 12–15, 40 pts for ≥16 chars).</a:t>
             </a:r>
           </a:p>
           <a:p>
             <a:pPr>
               <a:spcAft>
-                <a:spcPts val="600"/>
+                <a:spcPts val="500"/>
               </a:spcAft>
               <a:defRPr sz="1000" b="0" i="0">
                 <a:solidFill>
@@ -8316,13 +8332,13 @@
               </a:defRPr>
             </a:pPr>
             <a:r>
-              <a:t>• Character Variety: Up to 35 points (Lowercase +5, Uppercase +10, Digits +10, Symbols +10).</a:t>
+              <a:t>• Character Variety: Up to 35 pts (lowercase +8, uppercase +8, digits +9, symbols +10).</a:t>
             </a:r>
           </a:p>
           <a:p>
             <a:pPr>
               <a:spcAft>
-                <a:spcPts val="600"/>
+                <a:spcPts val="500"/>
               </a:spcAft>
               <a:defRPr sz="1000" b="0" i="0">
                 <a:solidFill>
@@ -8332,13 +8348,13 @@
               </a:defRPr>
             </a:pPr>
             <a:r>
-              <a:t>• Structural Diversity: Up to 15 bonus points (2 types: +5, 3 types: +10, all 4 types: +15).</a:t>
+              <a:t>• Diversity Bonus: Up to 15 bonus pts (2 pools: +3, 3 pools: +8, 4 pools: +15).</a:t>
             </a:r>
           </a:p>
           <a:p>
             <a:pPr>
               <a:spcAft>
-                <a:spcPts val="600"/>
+                <a:spcPts val="500"/>
               </a:spcAft>
               <a:defRPr sz="1000" b="0" i="0">
                 <a:solidFill>
@@ -8348,13 +8364,13 @@
               </a:defRPr>
             </a:pPr>
             <a:r>
-              <a:t>• Passphrase Bonus: +10 bonus points for strings ≥16 chars with whitespace/hyphen word boundaries.</a:t>
+              <a:t>• Passphrase Bonus: Up to 20 bonus pts (20 pts for length ≥20 with ≥10 unique chars; 15 pts for ≥16 with word delimiters).</a:t>
             </a:r>
           </a:p>
           <a:p>
             <a:pPr>
               <a:spcAft>
-                <a:spcPts val="600"/>
+                <a:spcPts val="500"/>
               </a:spcAft>
               <a:defRPr sz="1000" b="0" i="0">
                 <a:solidFill>
@@ -8364,7 +8380,7 @@
               </a:defRPr>
             </a:pPr>
             <a:r>
-              <a:t>• Subtractive Penalties: Sequential characters (-15), repeated runs (-15), known dictionary patterns (-25).</a:t>
+              <a:t>• Subtractive Penalties: Sequential runs (-15), repeated chars (-15), dictionary roots (-25), length under 12 (-8 or -20), single pool (-15).</a:t>
             </a:r>
           </a:p>
           <a:p>
@@ -8576,7 +8592,7 @@
               </a:defRPr>
             </a:pPr>
             <a:r>
-              <a:t>(Upper bound estimate under uniform-character assumption)</a:t>
+              <a:t>(Upper-bound estimate under uniform-character assumption)</a:t>
             </a:r>
           </a:p>
           <a:p>
@@ -8608,7 +8624,7 @@
               </a:defRPr>
             </a:pPr>
             <a:r>
-              <a:t>• 100 guesses/sec: Simulates an online authentication endpoint with aggressive network rate-limiting and lockout.</a:t>
+              <a:t>• 100 guesses/sec: Illustrative rate modeling a throttled online login endpoint.</a:t>
             </a:r>
           </a:p>
           <a:p>
@@ -8624,7 +8640,7 @@
               </a:defRPr>
             </a:pPr>
             <a:r>
-              <a:t>• 10,000,000 guesses/sec (10⁷): Simulates standard multi-threaded CPU offline guessing against a moderately fast hash.</a:t>
+              <a:t>• 10,000,000 guesses/sec (10⁷): Illustrative rate modeling standard CPU offline recovery.</a:t>
             </a:r>
           </a:p>
           <a:p>
@@ -8640,7 +8656,7 @@
               </a:defRPr>
             </a:pPr>
             <a:r>
-              <a:t>• 100,000,000,000 guesses/sec (10¹¹): Simulates high-end parallel GPU clusters targeting unsalted fast hashes (e.g. SHA-256).</a:t>
+              <a:t>• 100,000,000,000 guesses/sec (10¹¹): Illustrative rate modeling high-end hardware targeting fast hashes.</a:t>
             </a:r>
           </a:p>
           <a:p>
@@ -8653,7 +8669,7 @@
               </a:defRPr>
             </a:pPr>
             <a:r>
-              <a:t>• Educational Qualification: These rates are illustrative mathematical projections, NOT physical cracking benchmarks.</a:t>
+              <a:t>• Educational Note: These rates are illustrative assumed scenarios, NOT physical hardware benchmarks.</a:t>
             </a:r>
           </a:p>
         </p:txBody>
@@ -9001,7 +9017,7 @@
               </a:defRPr>
             </a:pPr>
             <a:r>
-              <a:t>Changing a single character flips over 50% of output bits pseudorandomly, preventing incremental clues.</a:t>
+              <a:t>A well-designed cryptographic hash exhibits an avalanche effect: a small input change tends to change roughly half of the output bits.</a:t>
             </a:r>
           </a:p>
           <a:p>
@@ -9017,7 +9033,7 @@
               </a:defRPr>
             </a:pPr>
             <a:r>
-              <a:t>• The Fast Hash Flaw:</a:t>
+              <a:t>• Fast Hashes in Security:</a:t>
             </a:r>
           </a:p>
           <a:p>
@@ -9030,7 +9046,7 @@
               </a:defRPr>
             </a:pPr>
             <a:r>
-              <a:t>General-purpose hashes (SHA-256, MD5) are engineered for maximum throughput, allowing attackers to test billions of guesses per second if a database leaks.</a:t>
+              <a:t>SHA-256 is designed to be fast for digital signatures and file integrity, but this throughput makes password guessing cheaper if hashes leak.</a:t>
             </a:r>
           </a:p>
         </p:txBody>
@@ -9213,7 +9229,7 @@
               </a:defRPr>
             </a:pPr>
             <a:r>
-              <a:t>A unique, cryptographically random salt generated per user via crypto.getRandomValues().</a:t>
+              <a:t>A unique random salt generated per user via crypto.getRandomValues().</a:t>
             </a:r>
           </a:p>
           <a:p>
@@ -9229,7 +9245,7 @@
               </a:defRPr>
             </a:pPr>
             <a:r>
-              <a:t>• Digest Uniqueness:</a:t>
+              <a:t>• Stored Digest Uniqueness:</a:t>
             </a:r>
           </a:p>
           <a:p>
@@ -9245,7 +9261,7 @@
               </a:defRPr>
             </a:pPr>
             <a:r>
-              <a:t>Even if 1,000 users share the exact same password, each user gets a completely distinct stored hash.</a:t>
+              <a:t>A sufficiently large random salt makes identical passwords overwhelmingly likely to produce different stored verifier values.</a:t>
             </a:r>
           </a:p>
           <a:p>
@@ -9261,7 +9277,7 @@
               </a:defRPr>
             </a:pPr>
             <a:r>
-              <a:t>• Rainbow Table Invalidation:</a:t>
+              <a:t>• Neutralizes Rainbow Tables:</a:t>
             </a:r>
           </a:p>
           <a:p>
@@ -9277,7 +9293,7 @@
               </a:defRPr>
             </a:pPr>
             <a:r>
-              <a:t>Precomputed plaintext-to-hash lookup tables become useless because the table cannot predict random per-user salts.</a:t>
+              <a:t>Unique salts make traditional precomputed rainbow-table attacks impractical across many users.</a:t>
             </a:r>
           </a:p>
           <a:p>
@@ -9293,7 +9309,7 @@
               </a:defRPr>
             </a:pPr>
             <a:r>
-              <a:t>• Forced Individual Cracking:</a:t>
+              <a:t>• Independent Attacks Required:</a:t>
             </a:r>
           </a:p>
           <a:p>
@@ -9306,7 +9322,7 @@
               </a:defRPr>
             </a:pPr>
             <a:r>
-              <a:t>Attackers must spend full computing budget attacking each account individually.</a:t>
+              <a:t>Attackers must spend computational budget attacking each account separately.</a:t>
             </a:r>
           </a:p>
         </p:txBody>
@@ -9473,7 +9489,7 @@
               </a:defRPr>
             </a:pPr>
             <a:r>
-              <a:t>• Educational Notice:</a:t>
+              <a:t>• Educational Demo Notice:</a:t>
             </a:r>
           </a:p>
           <a:p>
@@ -9505,7 +9521,7 @@
               </a:defRPr>
             </a:pPr>
             <a:r>
-              <a:t>• Why Fast Hashes Fail:</a:t>
+              <a:t>• Raw Fast Hashes Unsuitable:</a:t>
             </a:r>
           </a:p>
           <a:p>
@@ -9521,7 +9537,7 @@
               </a:defRPr>
             </a:pPr>
             <a:r>
-              <a:t>SHA-256 uses simple arithmetic logic and minimal memory, making it vulnerable to massive GPU/ASIC acceleration.</a:t>
+              <a:t>Raw SHA-256 is not appropriate for production password storage because it lacks memory-hardness.</a:t>
             </a:r>
           </a:p>
           <a:p>
@@ -9537,7 +9553,7 @@
               </a:defRPr>
             </a:pPr>
             <a:r>
-              <a:t>• Memory-Hard KDFs Required:</a:t>
+              <a:t>• Password-Focused KDFs:</a:t>
             </a:r>
           </a:p>
           <a:p>
@@ -9553,7 +9569,7 @@
               </a:defRPr>
             </a:pPr>
             <a:r>
-              <a:t>Production credential stores MUST use slow Key Derivation Functions: Argon2id (IETF RFC 9106), bcrypt, or scrypt.</a:t>
+              <a:t>Production systems should use dedicated functions: Argon2id (IETF RFC 9106), bcrypt, scrypt, or PBKDF2.</a:t>
             </a:r>
           </a:p>
           <a:p>
@@ -9582,7 +9598,7 @@
               </a:defRPr>
             </a:pPr>
             <a:r>
-              <a:t>KDFs intentionally consume high RAM and CPU time, rendering large-scale offline brute force economically infeasible.</a:t>
+              <a:t>Dedicated KDFs deliberately increase the time and memory cost of each guess.</a:t>
             </a:r>
           </a:p>
         </p:txBody>

</xml_diff>